<commit_message>
feat(danal): expand verification PPTX to 11 slides with point charge, usage, refund terms and usage restriction matching PG sample
</commit_message>
<xml_diff>
--- a/신용카드 검수요청서(럭키픽).pptx
+++ b/신용카드 검수요청서(럭키픽).pptx
@@ -13,6 +13,9 @@
     <p:sldId id="278" r:id="rId7"/>
     <p:sldId id="266" r:id="rId8"/>
     <p:sldId id="280" r:id="rId9"/>
+    <p:sldId id="282" r:id="rId10"/>
+    <p:sldId id="272" r:id="rId11"/>
+    <p:sldId id="275" r:id="rId12"/>
   </p:sldIdLst>
   <p:sldSz cx="9906000" cy="6858000" type="A4"/>
   <p:notesSz cx="6858000" cy="9144000"/>
@@ -7393,7 +7396,11 @@
           <a:lstStyle/>
           <a:p>
             <a:pPr>
-              <a:defRPr b="1" sz="2800"/>
+              <a:defRPr b="1" sz="2800">
+                <a:solidFill>
+                  <a:srgbClr val="1A202C"/>
+                </a:solidFill>
+              </a:defRPr>
             </a:pPr>
             <a:r>
               <a:t>럭키픽 (LuckyPick)</a:t>
@@ -7465,7 +7472,11 @@
           <a:lstStyle/>
           <a:p>
             <a:pPr>
-              <a:defRPr sz="1300"/>
+              <a:defRPr sz="1300">
+                <a:solidFill>
+                  <a:srgbClr val="374151"/>
+                </a:solidFill>
+              </a:defRPr>
             </a:pPr>
             <a:r>
               <a:t>서비스 URL: https://luckypick-ec4cf.web.app</a:t>
@@ -7473,7 +7484,11 @@
           </a:p>
           <a:p>
             <a:pPr>
-              <a:defRPr sz="1300"/>
+              <a:defRPr sz="1300">
+                <a:solidFill>
+                  <a:srgbClr val="374151"/>
+                </a:solidFill>
+              </a:defRPr>
             </a:pPr>
             <a:r>
               <a:t>상호(법인명): 럭키픽 | 대표자: 이재영</a:t>
@@ -7481,7 +7496,11 @@
           </a:p>
           <a:p>
             <a:pPr>
-              <a:defRPr sz="1300"/>
+              <a:defRPr sz="1300">
+                <a:solidFill>
+                  <a:srgbClr val="374151"/>
+                </a:solidFill>
+              </a:defRPr>
             </a:pPr>
             <a:r>
               <a:t>사업자등록번호: 803-05-03449 | 통신판매업: 제 2026-화성새솔-0099 호</a:t>
@@ -7489,7 +7508,11 @@
           </a:p>
           <a:p>
             <a:pPr>
-              <a:defRPr sz="1300"/>
+              <a:defRPr sz="1300">
+                <a:solidFill>
+                  <a:srgbClr val="374151"/>
+                </a:solidFill>
+              </a:defRPr>
             </a:pPr>
             <a:r>
               <a:t>고객센터: 070-8019-3205 | 이메일: leejeayoung0713@gmail.com</a:t>
@@ -7497,7 +7520,11 @@
           </a:p>
           <a:p>
             <a:pPr>
-              <a:defRPr sz="1300"/>
+              <a:defRPr sz="1300">
+                <a:solidFill>
+                  <a:srgbClr val="374151"/>
+                </a:solidFill>
+              </a:defRPr>
             </a:pPr>
             <a:r>
               <a:t>사업장 소재지: 경기도 화성시 만세구 수노을1로 148, 101동 902호</a:t>
@@ -7505,7 +7532,11 @@
           </a:p>
           <a:p>
             <a:pPr>
-              <a:defRPr sz="1300"/>
+              <a:defRPr sz="1300">
+                <a:solidFill>
+                  <a:srgbClr val="374151"/>
+                </a:solidFill>
+              </a:defRPr>
             </a:pPr>
             <a:r>
               <a:t>TEST 계정: ID: tester@luckypick.kr / PW: LuckyPick2026!</a:t>
@@ -7513,7 +7544,11 @@
           </a:p>
           <a:p>
             <a:pPr>
-              <a:defRPr sz="1300"/>
+              <a:defRPr sz="1300">
+                <a:solidFill>
+                  <a:srgbClr val="374151"/>
+                </a:solidFill>
+              </a:defRPr>
             </a:pPr>
             <a:r>
               <a:t>신청 서비스: 휴대폰 소액결제(APP), 신용카드 결제(일반/간편)</a:t>
@@ -7521,10 +7556,14 @@
           </a:p>
           <a:p>
             <a:pPr>
-              <a:defRPr sz="1300"/>
+              <a:defRPr sz="1300">
+                <a:solidFill>
+                  <a:srgbClr val="374151"/>
+                </a:solidFill>
+              </a:defRPr>
             </a:pPr>
             <a:r>
-              <a:t>작성일자: 2026. 10. 20</a:t>
+              <a:t>작성일자: 2026. 10. 21</a:t>
             </a:r>
           </a:p>
         </p:txBody>
@@ -7579,6 +7618,379 @@
     <p:extLst>
       <p:ext uri="{BB962C8B-B14F-4D97-AF65-F5344CB8AC3E}">
         <p14:creationId xmlns:p14="http://schemas.microsoft.com/office/powerpoint/2010/main" val="2336413712"/>
+      </p:ext>
+    </p:extLst>
+  </p:cSld>
+  <p:clrMapOvr>
+    <a:masterClrMapping/>
+  </p:clrMapOvr>
+  <p:timing>
+    <p:tnLst>
+      <p:par>
+        <p:cTn id="1" dur="indefinite" restart="never" nodeType="tmRoot"/>
+      </p:par>
+    </p:tnLst>
+  </p:timing>
+</p:sld>
+</file>
+
+<file path=ppt/slides/slide10.xml><?xml version="1.0" encoding="utf-8"?>
+<p:sld xmlns:a="http://schemas.openxmlformats.org/drawingml/2006/main" xmlns:r="http://schemas.openxmlformats.org/officeDocument/2006/relationships" xmlns:p="http://schemas.openxmlformats.org/presentationml/2006/main">
+  <p:cSld>
+    <p:spTree>
+      <p:nvGrpSpPr>
+        <p:cNvPr id="1" name=""/>
+        <p:cNvGrpSpPr/>
+        <p:nvPr/>
+      </p:nvGrpSpPr>
+      <p:grpSpPr>
+        <a:xfrm>
+          <a:off x="0" y="0"/>
+          <a:ext cx="0" cy="0"/>
+          <a:chOff x="0" y="0"/>
+          <a:chExt cx="0" cy="0"/>
+        </a:xfrm>
+      </p:grpSpPr>
+      <p:sp>
+        <p:nvSpPr>
+          <p:cNvPr id="2" name="TextBox 1"/>
+          <p:cNvSpPr txBox="1"/>
+          <p:nvPr/>
+        </p:nvSpPr>
+        <p:spPr>
+          <a:xfrm>
+            <a:off x="300000" y="120000"/>
+            <a:ext cx="9300000" cy="650000"/>
+          </a:xfrm>
+          <a:prstGeom prst="rect">
+            <a:avLst/>
+          </a:prstGeom>
+          <a:noFill/>
+        </p:spPr>
+        <p:txBody>
+          <a:bodyPr wrap="square">
+            <a:spAutoFit/>
+          </a:bodyPr>
+          <a:lstStyle/>
+          <a:p>
+            <a:pPr>
+              <a:defRPr b="1" sz="1700">
+                <a:solidFill>
+                  <a:srgbClr val="1E293B"/>
+                </a:solidFill>
+              </a:defRPr>
+            </a:pPr>
+            <a:r>
+              <a:t>포인트 사용처</a:t>
+            </a:r>
+          </a:p>
+        </p:txBody>
+      </p:sp>
+      <p:sp>
+        <p:nvSpPr>
+          <p:cNvPr id="3" name="TextBox 2"/>
+          <p:cNvSpPr txBox="1"/>
+          <p:nvPr/>
+        </p:nvSpPr>
+        <p:spPr>
+          <a:xfrm>
+            <a:off x="600000" y="1600000"/>
+            <a:ext cx="8700000" cy="1000000"/>
+          </a:xfrm>
+          <a:prstGeom prst="rect">
+            <a:avLst/>
+          </a:prstGeom>
+          <a:noFill/>
+        </p:spPr>
+        <p:txBody>
+          <a:bodyPr wrap="square">
+            <a:spAutoFit/>
+          </a:bodyPr>
+          <a:lstStyle/>
+          <a:p>
+            <a:pPr algn="l">
+              <a:defRPr b="1" sz="2600">
+                <a:solidFill>
+                  <a:srgbClr val="DC2626"/>
+                </a:solidFill>
+              </a:defRPr>
+            </a:pPr>
+            <a:r>
+              <a:t>해당 사이트에서만 포인트 사용이 가능합니다.</a:t>
+            </a:r>
+          </a:p>
+        </p:txBody>
+      </p:sp>
+      <p:sp>
+        <p:nvSpPr>
+          <p:cNvPr id="4" name="TextBox 3"/>
+          <p:cNvSpPr txBox="1"/>
+          <p:nvPr/>
+        </p:nvSpPr>
+        <p:spPr>
+          <a:xfrm>
+            <a:off x="600000" y="2700000"/>
+            <a:ext cx="8700000" cy="3600000"/>
+          </a:xfrm>
+          <a:prstGeom prst="rect">
+            <a:avLst/>
+          </a:prstGeom>
+          <a:noFill/>
+        </p:spPr>
+        <p:txBody>
+          <a:bodyPr wrap="square">
+            <a:spAutoFit/>
+          </a:bodyPr>
+          <a:lstStyle/>
+          <a:p>
+            <a:pPr>
+              <a:spcBef>
+                <a:spcPts val="800"/>
+              </a:spcBef>
+              <a:defRPr b="1" sz="1400">
+                <a:solidFill>
+                  <a:srgbClr val="0F172A"/>
+                </a:solidFill>
+              </a:defRPr>
+            </a:pPr>
+            <a:r>
+              <a:t>1. 포인트 사용 가능 사이트</a:t>
+            </a:r>
+          </a:p>
+          <a:p>
+            <a:pPr>
+              <a:spcAft>
+                <a:spcPts val="600"/>
+              </a:spcAft>
+              <a:defRPr sz="1200">
+                <a:solidFill>
+                  <a:srgbClr val="475569"/>
+                </a:solidFill>
+              </a:defRPr>
+            </a:pPr>
+            <a:r>
+              <a:t>• 공식 서비스 URL: https://luckypick-ec4cf.web.app (럭키픽 온라인 플랫폼 전용)</a:t>
+            </a:r>
+            <a:br/>
+            <a:r>
+              <a:t>• 당사 사이트 외 타 사이트, 오프라인 매장 등에서는 일체 사용이 불가능합니다.</a:t>
+            </a:r>
+          </a:p>
+          <a:p>
+            <a:pPr>
+              <a:spcBef>
+                <a:spcPts val="800"/>
+              </a:spcBef>
+              <a:defRPr b="1" sz="1400">
+                <a:solidFill>
+                  <a:srgbClr val="0F172A"/>
+                </a:solidFill>
+              </a:defRPr>
+            </a:pPr>
+            <a:r>
+              <a:t>2. 포인트 사용 용도</a:t>
+            </a:r>
+          </a:p>
+          <a:p>
+            <a:pPr>
+              <a:spcAft>
+                <a:spcPts val="600"/>
+              </a:spcAft>
+              <a:defRPr sz="1200">
+                <a:solidFill>
+                  <a:srgbClr val="475569"/>
+                </a:solidFill>
+              </a:defRPr>
+            </a:pPr>
+            <a:r>
+              <a:t>• 럭키픽 플랫폼 내 블라인드 큐레이션 럭키박스(베이직, 프리미엄, VIP) 개봉 이용</a:t>
+            </a:r>
+            <a:br/>
+            <a:r>
+              <a:t>• 실물 득템 상품 보관함 출고 시 택배 배송비(3,000P) 결제 이용</a:t>
+            </a:r>
+          </a:p>
+          <a:p>
+            <a:pPr>
+              <a:spcBef>
+                <a:spcPts val="800"/>
+              </a:spcBef>
+              <a:defRPr b="1" sz="1400">
+                <a:solidFill>
+                  <a:srgbClr val="0F172A"/>
+                </a:solidFill>
+              </a:defRPr>
+            </a:pPr>
+            <a:r>
+              <a:t>3. 환금성 및 외부 유출 원천 차단 (비환금성 준수)</a:t>
+            </a:r>
+          </a:p>
+          <a:p>
+            <a:pPr>
+              <a:spcAft>
+                <a:spcPts val="600"/>
+              </a:spcAft>
+              <a:defRPr sz="1200">
+                <a:solidFill>
+                  <a:srgbClr val="475569"/>
+                </a:solidFill>
+              </a:defRPr>
+            </a:pPr>
+            <a:r>
+              <a:t>• 현금 환전 및 계좌 인출이 절대 불가능합니다. (환금성 0%)</a:t>
+            </a:r>
+            <a:br/>
+            <a:r>
+              <a:t>• 회원 간 포인트 선물, 양도, 이전 및 장외 개인 간 거래가 시스템상 원천 차단되어 있습니다.</a:t>
+            </a:r>
+          </a:p>
+          <a:p>
+            <a:pPr>
+              <a:spcBef>
+                <a:spcPts val="800"/>
+              </a:spcBef>
+              <a:defRPr b="1" sz="1400">
+                <a:solidFill>
+                  <a:srgbClr val="0F172A"/>
+                </a:solidFill>
+              </a:defRPr>
+            </a:pPr>
+            <a:r>
+              <a:t>4. 미사용 포인트 청약철회 및 환불 원칙</a:t>
+            </a:r>
+          </a:p>
+          <a:p>
+            <a:pPr>
+              <a:spcAft>
+                <a:spcPts val="600"/>
+              </a:spcAft>
+              <a:defRPr sz="1200">
+                <a:solidFill>
+                  <a:srgbClr val="475569"/>
+                </a:solidFill>
+              </a:defRPr>
+            </a:pPr>
+            <a:r>
+              <a:t>• 유료 결제로 충전한 후 사용하지 않은 잔여 포인트는 결제일로부터 7일 이내 요청 시 구매자의 원 결제수단(신용카드 승인 취소, 휴대폰 소액결제 승인 취소)으로 100% 전액 환불 처리됩니다.</a:t>
+            </a:r>
+            <a:br/>
+            <a:r>
+              <a:t>• 별도의 현금 지급이나 계좌 송금 형태의 환불은 전자상거래법 및 PG사 규정에 따라 불가합니다.</a:t>
+            </a:r>
+          </a:p>
+        </p:txBody>
+      </p:sp>
+    </p:spTree>
+    <p:extLst>
+      <p:ext uri="{BB962C8B-B14F-4D97-AF65-F5344CB8AC3E}">
+        <p14:creationId xmlns:p14="http://schemas.microsoft.com/office/powerpoint/2010/main" val="791979586"/>
+      </p:ext>
+    </p:extLst>
+  </p:cSld>
+  <p:clrMapOvr>
+    <a:masterClrMapping/>
+  </p:clrMapOvr>
+  <p:timing>
+    <p:tnLst>
+      <p:par>
+        <p:cTn id="1" dur="indefinite" restart="never" nodeType="tmRoot"/>
+      </p:par>
+    </p:tnLst>
+  </p:timing>
+</p:sld>
+</file>
+
+<file path=ppt/slides/slide11.xml><?xml version="1.0" encoding="utf-8"?>
+<p:sld xmlns:a="http://schemas.openxmlformats.org/drawingml/2006/main" xmlns:r="http://schemas.openxmlformats.org/officeDocument/2006/relationships" xmlns:p="http://schemas.openxmlformats.org/presentationml/2006/main">
+  <p:cSld>
+    <p:spTree>
+      <p:nvGrpSpPr>
+        <p:cNvPr id="1" name=""/>
+        <p:cNvGrpSpPr/>
+        <p:nvPr/>
+      </p:nvGrpSpPr>
+      <p:grpSpPr>
+        <a:xfrm>
+          <a:off x="0" y="0"/>
+          <a:ext cx="0" cy="0"/>
+          <a:chOff x="0" y="0"/>
+          <a:chExt cx="0" cy="0"/>
+        </a:xfrm>
+      </p:grpSpPr>
+      <p:sp>
+        <p:nvSpPr>
+          <p:cNvPr id="2" name="TextBox 1"/>
+          <p:cNvSpPr txBox="1"/>
+          <p:nvPr/>
+        </p:nvSpPr>
+        <p:spPr>
+          <a:xfrm>
+            <a:off x="1000000" y="2600000"/>
+            <a:ext cx="7900000" cy="1200000"/>
+          </a:xfrm>
+          <a:prstGeom prst="rect">
+            <a:avLst/>
+          </a:prstGeom>
+          <a:noFill/>
+        </p:spPr>
+        <p:txBody>
+          <a:bodyPr wrap="none">
+            <a:spAutoFit/>
+          </a:bodyPr>
+          <a:lstStyle/>
+          <a:p>
+            <a:pPr algn="ctr">
+              <a:defRPr b="1" sz="4000">
+                <a:solidFill>
+                  <a:srgbClr val="1E293B"/>
+                </a:solidFill>
+              </a:defRPr>
+            </a:pPr>
+            <a:r>
+              <a:t>감사합니다.</a:t>
+            </a:r>
+          </a:p>
+        </p:txBody>
+      </p:sp>
+      <p:sp>
+        <p:nvSpPr>
+          <p:cNvPr id="3" name="TextBox 2"/>
+          <p:cNvSpPr txBox="1"/>
+          <p:nvPr/>
+        </p:nvSpPr>
+        <p:spPr>
+          <a:xfrm>
+            <a:off x="1000000" y="6300000"/>
+            <a:ext cx="7900000" cy="400000"/>
+          </a:xfrm>
+          <a:prstGeom prst="rect">
+            <a:avLst/>
+          </a:prstGeom>
+          <a:noFill/>
+        </p:spPr>
+        <p:txBody>
+          <a:bodyPr wrap="none">
+            <a:spAutoFit/>
+          </a:bodyPr>
+          <a:lstStyle/>
+          <a:p>
+            <a:pPr algn="ctr">
+              <a:defRPr sz="1000">
+                <a:solidFill>
+                  <a:srgbClr val="94A3B8"/>
+                </a:solidFill>
+              </a:defRPr>
+            </a:pPr>
+            <a:r>
+              <a:t>Corporate Introduction @ DANAL Co., Ltd. All Rights Reserved.</a:t>
+            </a:r>
+          </a:p>
+        </p:txBody>
+      </p:sp>
+    </p:spTree>
+    <p:extLst>
+      <p:ext uri="{BB962C8B-B14F-4D97-AF65-F5344CB8AC3E}">
+        <p14:creationId xmlns:p14="http://schemas.microsoft.com/office/powerpoint/2010/main" val="1404916672"/>
       </p:ext>
     </p:extLst>
   </p:cSld>
@@ -7624,14 +8036,30 @@
         </p:nvSpPr>
         <p:spPr/>
         <p:txBody>
-          <a:bodyPr/>
+          <a:bodyPr wrap="square"/>
           <a:lstStyle/>
           <a:p>
             <a:pPr>
-              <a:defRPr b="1" sz="1800"/>
+              <a:defRPr b="1" sz="1700">
+                <a:solidFill>
+                  <a:srgbClr val="1E293B"/>
+                </a:solidFill>
+              </a:defRPr>
             </a:pPr>
             <a:r>
-              <a:t>앱 메인 화면 (URL 노출 캡쳐)</a:t>
+              <a:t>① 사이트 메인 (URL노출 캡쳐)</a:t>
+            </a:r>
+          </a:p>
+          <a:p>
+            <a:pPr>
+              <a:defRPr b="0" sz="1300">
+                <a:solidFill>
+                  <a:srgbClr val="475569"/>
+                </a:solidFill>
+              </a:defRPr>
+            </a:pPr>
+            <a:r>
+              <a:t>서비스 URL (https://luckypick-ec4cf.web.app) 상단 주소창 노출</a:t>
             </a:r>
           </a:p>
         </p:txBody>
@@ -7652,7 +8080,7 @@
         </p:blipFill>
         <p:spPr>
           <a:xfrm>
-            <a:off x="400000" y="1164606"/>
+            <a:off x="400000" y="1214606"/>
             <a:ext cx="9106000" cy="4970787"/>
           </a:xfrm>
           <a:prstGeom prst="rect">
@@ -7709,14 +8137,30 @@
         </p:nvSpPr>
         <p:spPr/>
         <p:txBody>
-          <a:bodyPr/>
+          <a:bodyPr wrap="square"/>
           <a:lstStyle/>
           <a:p>
             <a:pPr>
-              <a:defRPr b="1" sz="1800"/>
+              <a:defRPr b="1" sz="1700">
+                <a:solidFill>
+                  <a:srgbClr val="1E293B"/>
+                </a:solidFill>
+              </a:defRPr>
             </a:pPr>
             <a:r>
-              <a:t>앱 메인_하단정보 (상호, 사업자번호, 대표자, 고객센터 070번호 노출)</a:t>
+              <a:t>② 사이트 메인 하단정보 ※상호명, 사업자번호, 유선번호, 소재지, 대표자명 기재必</a:t>
+            </a:r>
+          </a:p>
+          <a:p>
+            <a:pPr>
+              <a:defRPr b="0" sz="1300">
+                <a:solidFill>
+                  <a:srgbClr val="475569"/>
+                </a:solidFill>
+              </a:defRPr>
+            </a:pPr>
+            <a:r>
+              <a:t>상호: 럭키픽 | 대표: 이재영 | 사업자번호: 803-05-03449 | 고객센터: 070-8019-3205</a:t>
             </a:r>
           </a:p>
         </p:txBody>
@@ -7737,8 +8181,8 @@
         </p:blipFill>
         <p:spPr>
           <a:xfrm>
-            <a:off x="1708404" y="750000"/>
-            <a:ext cx="6489191" cy="5800000"/>
+            <a:off x="1764346" y="850000"/>
+            <a:ext cx="6377308" cy="5700000"/>
           </a:xfrm>
           <a:prstGeom prst="rect">
             <a:avLst/>
@@ -7794,21 +8238,84 @@
         </p:nvSpPr>
         <p:spPr/>
         <p:txBody>
-          <a:bodyPr/>
+          <a:bodyPr wrap="square"/>
           <a:lstStyle/>
           <a:p>
             <a:pPr>
-              <a:defRPr b="1" sz="1800"/>
+              <a:defRPr b="1" sz="1700">
+                <a:solidFill>
+                  <a:srgbClr val="1E293B"/>
+                </a:solidFill>
+              </a:defRPr>
             </a:pPr>
             <a:r>
-              <a:t>상품 선택 &gt; 럭키박스 라인업 및 투명 확률 공개 (베이직 5천원 / 프리미엄 1만원 / VIP 2만원)</a:t>
+              <a:t>③ 상품 및 포인트 충전 결제 프로세스 ※ 결제진행상품금액동일/ 금액임의입력불가</a:t>
+            </a:r>
+          </a:p>
+          <a:p>
+            <a:pPr>
+              <a:defRPr b="0" sz="1300">
+                <a:solidFill>
+                  <a:srgbClr val="475569"/>
+                </a:solidFill>
+              </a:defRPr>
+            </a:pPr>
+            <a:r>
+              <a:t>정찰제 패키지 선택 (10,000P / 32,000P / 55,000P / 115,000P), 금액 임의 수정 불가</a:t>
+            </a:r>
+          </a:p>
+        </p:txBody>
+      </p:sp>
+      <p:sp>
+        <p:nvSpPr>
+          <p:cNvPr id="3" name="TextBox 2"/>
+          <p:cNvSpPr txBox="1"/>
+          <p:nvPr/>
+        </p:nvSpPr>
+        <p:spPr>
+          <a:xfrm>
+            <a:off x="6800000" y="120000"/>
+            <a:ext cx="2800000" cy="500000"/>
+          </a:xfrm>
+          <a:prstGeom prst="rect">
+            <a:avLst/>
+          </a:prstGeom>
+          <a:noFill/>
+        </p:spPr>
+        <p:txBody>
+          <a:bodyPr wrap="none">
+            <a:spAutoFit/>
+          </a:bodyPr>
+          <a:lstStyle/>
+          <a:p>
+            <a:pPr algn="r">
+              <a:defRPr sz="1100" b="1">
+                <a:solidFill>
+                  <a:srgbClr val="DC2626"/>
+                </a:solidFill>
+              </a:defRPr>
+            </a:pPr>
+            <a:r>
+              <a:t>TEST ID : tester@luckypick.kr</a:t>
+            </a:r>
+          </a:p>
+          <a:p>
+            <a:pPr algn="r">
+              <a:defRPr sz="1100" b="1">
+                <a:solidFill>
+                  <a:srgbClr val="DC2626"/>
+                </a:solidFill>
+              </a:defRPr>
+            </a:pPr>
+            <a:r>
+              <a:t>TEST PW : LuckyPick2026!</a:t>
             </a:r>
           </a:p>
         </p:txBody>
       </p:sp>
       <p:pic>
         <p:nvPicPr>
-          <p:cNvPr id="3" name="Picture 2" descr="03_products_list.png"/>
+          <p:cNvPr id="4" name="Picture 3" descr="07_point_charge_section.png"/>
           <p:cNvPicPr>
             <a:picLocks noChangeAspect="1"/>
           </p:cNvPicPr>
@@ -7822,8 +8329,8 @@
         </p:blipFill>
         <p:spPr>
           <a:xfrm>
-            <a:off x="1203868" y="750000"/>
-            <a:ext cx="7498263" cy="5800000"/>
+            <a:off x="899667" y="850000"/>
+            <a:ext cx="8106666" cy="5700000"/>
           </a:xfrm>
           <a:prstGeom prst="rect">
             <a:avLst/>
@@ -7879,21 +8386,84 @@
         </p:nvSpPr>
         <p:spPr/>
         <p:txBody>
-          <a:bodyPr/>
+          <a:bodyPr wrap="square"/>
           <a:lstStyle/>
           <a:p>
             <a:pPr>
-              <a:defRPr b="1" sz="1800"/>
+              <a:defRPr b="1" sz="1700">
+                <a:solidFill>
+                  <a:srgbClr val="1E293B"/>
+                </a:solidFill>
+              </a:defRPr>
             </a:pPr>
             <a:r>
-              <a:t>신용카드 / 휴대폰 결제창 연동 (정찰제 ₩5,000원, 금액 임의 입력 불가)</a:t>
+              <a:t>④ 결제창 연동 (포인트 충전 ₩10,000원 결제 수단 선택)</a:t>
+            </a:r>
+          </a:p>
+          <a:p>
+            <a:pPr>
+              <a:defRPr b="0" sz="1300">
+                <a:solidFill>
+                  <a:srgbClr val="475569"/>
+                </a:solidFill>
+              </a:defRPr>
+            </a:pPr>
+            <a:r>
+              <a:t>정찰제 ₩10,000원 결제 대상 &gt; 신용·체크카드 / 휴대폰 소액결제 선택창 호출</a:t>
+            </a:r>
+          </a:p>
+        </p:txBody>
+      </p:sp>
+      <p:sp>
+        <p:nvSpPr>
+          <p:cNvPr id="3" name="TextBox 2"/>
+          <p:cNvSpPr txBox="1"/>
+          <p:nvPr/>
+        </p:nvSpPr>
+        <p:spPr>
+          <a:xfrm>
+            <a:off x="6800000" y="120000"/>
+            <a:ext cx="2800000" cy="500000"/>
+          </a:xfrm>
+          <a:prstGeom prst="rect">
+            <a:avLst/>
+          </a:prstGeom>
+          <a:noFill/>
+        </p:spPr>
+        <p:txBody>
+          <a:bodyPr wrap="none">
+            <a:spAutoFit/>
+          </a:bodyPr>
+          <a:lstStyle/>
+          <a:p>
+            <a:pPr algn="r">
+              <a:defRPr sz="1100" b="1">
+                <a:solidFill>
+                  <a:srgbClr val="DC2626"/>
+                </a:solidFill>
+              </a:defRPr>
+            </a:pPr>
+            <a:r>
+              <a:t>TEST ID : tester@luckypick.kr</a:t>
+            </a:r>
+          </a:p>
+          <a:p>
+            <a:pPr algn="r">
+              <a:defRPr sz="1100" b="1">
+                <a:solidFill>
+                  <a:srgbClr val="DC2626"/>
+                </a:solidFill>
+              </a:defRPr>
+            </a:pPr>
+            <a:r>
+              <a:t>TEST PW : LuckyPick2026!</a:t>
             </a:r>
           </a:p>
         </p:txBody>
       </p:sp>
       <p:pic>
         <p:nvPicPr>
-          <p:cNvPr id="3" name="Picture 2" descr="media_1792502652944.png"/>
+          <p:cNvPr id="4" name="Picture 3" descr="08_point_charge_modal.png"/>
           <p:cNvPicPr>
             <a:picLocks noChangeAspect="1"/>
           </p:cNvPicPr>
@@ -7907,8 +8477,8 @@
         </p:blipFill>
         <p:spPr>
           <a:xfrm>
-            <a:off x="1780350" y="750000"/>
-            <a:ext cx="6345299" cy="5800000"/>
+            <a:off x="899667" y="850000"/>
+            <a:ext cx="8106666" cy="5700000"/>
           </a:xfrm>
           <a:prstGeom prst="rect">
             <a:avLst/>
@@ -7964,14 +8534,30 @@
         </p:nvSpPr>
         <p:spPr/>
         <p:txBody>
-          <a:bodyPr/>
+          <a:bodyPr wrap="square"/>
           <a:lstStyle/>
           <a:p>
             <a:pPr>
-              <a:defRPr b="1" sz="1800"/>
+              <a:defRPr b="1" sz="1700">
+                <a:solidFill>
+                  <a:srgbClr val="1E293B"/>
+                </a:solidFill>
+              </a:defRPr>
             </a:pPr>
             <a:r>
-              <a:t>다날 신용카드 표준결제창 호출 &gt; 각 카드사 선택 (베이직 럭키박스 5,000원 결제)</a:t>
+              <a:t>⑤ 각 카드사 인증창 호출 (다날 신용카드 표준결제창 호출)</a:t>
+            </a:r>
+          </a:p>
+          <a:p>
+            <a:pPr>
+              <a:defRPr b="0" sz="1300">
+                <a:solidFill>
+                  <a:srgbClr val="475569"/>
+                </a:solidFill>
+              </a:defRPr>
+            </a:pPr>
+            <a:r>
+              <a:t>다날 신용카드 표준 결제창 호출 &gt; 각 카드사 선택창 (10,000원 결제)</a:t>
             </a:r>
           </a:p>
         </p:txBody>
@@ -7992,8 +8578,8 @@
         </p:blipFill>
         <p:spPr>
           <a:xfrm>
-            <a:off x="1523901" y="750000"/>
-            <a:ext cx="6858198" cy="5800000"/>
+            <a:off x="1583023" y="850000"/>
+            <a:ext cx="6739953" cy="5700000"/>
           </a:xfrm>
           <a:prstGeom prst="rect">
             <a:avLst/>
@@ -8049,14 +8635,30 @@
         </p:nvSpPr>
         <p:spPr/>
         <p:txBody>
-          <a:bodyPr/>
+          <a:bodyPr wrap="square"/>
           <a:lstStyle/>
           <a:p>
             <a:pPr>
-              <a:defRPr b="1" sz="1800"/>
+              <a:defRPr b="1" sz="1700">
+                <a:solidFill>
+                  <a:srgbClr val="1E293B"/>
+                </a:solidFill>
+              </a:defRPr>
             </a:pPr>
             <a:r>
-              <a:t>다날 휴대폰 소액결제 연동창 호출 (SKT, KT, LGU+, 알뜰폰)</a:t>
+              <a:t>⑤ 휴대폰 소액결제 연동창 호출 (SKT, KT, LGU+, 알뜰폰)</a:t>
+            </a:r>
+          </a:p>
+          <a:p>
+            <a:pPr>
+              <a:defRPr b="0" sz="1300">
+                <a:solidFill>
+                  <a:srgbClr val="475569"/>
+                </a:solidFill>
+              </a:defRPr>
+            </a:pPr>
+            <a:r>
+              <a:t>다날 휴대폰 소액결제 연동창 호출 &gt; 통신 3사 및 알뜰폰 본인인증 결제창</a:t>
             </a:r>
           </a:p>
         </p:txBody>
@@ -8077,8 +8679,8 @@
         </p:blipFill>
         <p:spPr>
           <a:xfrm>
-            <a:off x="1753000" y="750000"/>
-            <a:ext cx="6400000" cy="5800000"/>
+            <a:off x="1808172" y="850000"/>
+            <a:ext cx="6289655" cy="5700000"/>
           </a:xfrm>
           <a:prstGeom prst="rect">
             <a:avLst/>
@@ -8130,8 +8732,8 @@
         </p:nvSpPr>
         <p:spPr>
           <a:xfrm>
-            <a:off x="266000" y="140000"/>
-            <a:ext cx="9400000" cy="450000"/>
+            <a:off x="300000" y="120000"/>
+            <a:ext cx="9300000" cy="650000"/>
           </a:xfrm>
           <a:prstGeom prst="rect">
             <a:avLst/>
@@ -8139,23 +8741,39 @@
           <a:noFill/>
         </p:spPr>
         <p:txBody>
-          <a:bodyPr wrap="none">
+          <a:bodyPr wrap="square">
             <a:spAutoFit/>
           </a:bodyPr>
           <a:lstStyle/>
           <a:p>
             <a:pPr>
-              <a:defRPr b="1" sz="1800"/>
+              <a:defRPr b="1" sz="1700">
+                <a:solidFill>
+                  <a:srgbClr val="1E293B"/>
+                </a:solidFill>
+              </a:defRPr>
             </a:pPr>
             <a:r>
-              <a:t>이용약관 및 취소 / 환불 정책 (개봉 전 7일 이내 원 결제수단 100% 환불 규정)</a:t>
+              <a:t>포인트 사용 프로세스</a:t>
+            </a:r>
+          </a:p>
+          <a:p>
+            <a:pPr>
+              <a:defRPr b="0" sz="1300">
+                <a:solidFill>
+                  <a:srgbClr val="475569"/>
+                </a:solidFill>
+              </a:defRPr>
+            </a:pPr>
+            <a:r>
+              <a:t>원하는 럭키박스 선택 후 개봉을 진행하면 충전된 포인트에서 차감됩니다</a:t>
             </a:r>
           </a:p>
         </p:txBody>
       </p:sp>
       <p:pic>
         <p:nvPicPr>
-          <p:cNvPr id="3" name="Picture 2" descr="05_refund_policy.png"/>
+          <p:cNvPr id="3" name="Picture 2" descr="09_point_use_process.png"/>
           <p:cNvPicPr>
             <a:picLocks noChangeAspect="1"/>
           </p:cNvPicPr>
@@ -8169,8 +8787,8 @@
         </p:blipFill>
         <p:spPr>
           <a:xfrm>
-            <a:off x="1708404" y="750000"/>
-            <a:ext cx="6489191" cy="5800000"/>
+            <a:off x="899667" y="850000"/>
+            <a:ext cx="8106666" cy="5700000"/>
           </a:xfrm>
           <a:prstGeom prst="rect">
             <a:avLst/>
@@ -8181,6 +8799,107 @@
     <p:extLst>
       <p:ext uri="{BB962C8B-B14F-4D97-AF65-F5344CB8AC3E}">
         <p14:creationId xmlns:p14="http://schemas.microsoft.com/office/powerpoint/2010/main" val="3687569956"/>
+      </p:ext>
+    </p:extLst>
+  </p:cSld>
+  <p:clrMapOvr>
+    <a:masterClrMapping/>
+  </p:clrMapOvr>
+  <p:timing>
+    <p:tnLst>
+      <p:par>
+        <p:cTn id="1" dur="indefinite" restart="never" nodeType="tmRoot"/>
+      </p:par>
+    </p:tnLst>
+  </p:timing>
+</p:sld>
+</file>
+
+<file path=ppt/slides/slide9.xml><?xml version="1.0" encoding="utf-8"?>
+<p:sld xmlns:a="http://schemas.openxmlformats.org/drawingml/2006/main" xmlns:r="http://schemas.openxmlformats.org/officeDocument/2006/relationships" xmlns:p="http://schemas.openxmlformats.org/presentationml/2006/main">
+  <p:cSld>
+    <p:spTree>
+      <p:nvGrpSpPr>
+        <p:cNvPr id="1" name=""/>
+        <p:cNvGrpSpPr/>
+        <p:nvPr/>
+      </p:nvGrpSpPr>
+      <p:grpSpPr>
+        <a:xfrm>
+          <a:off x="0" y="0"/>
+          <a:ext cx="0" cy="0"/>
+          <a:chOff x="0" y="0"/>
+          <a:chExt cx="0" cy="0"/>
+        </a:xfrm>
+      </p:grpSpPr>
+      <p:sp>
+        <p:nvSpPr>
+          <p:cNvPr id="2" name="텍스트 개체 틀 1"/>
+          <p:cNvSpPr>
+            <a:spLocks noGrp="1"/>
+          </p:cNvSpPr>
+          <p:nvPr>
+            <p:ph type="body" sz="quarter" idx="11"/>
+          </p:nvPr>
+        </p:nvSpPr>
+        <p:spPr/>
+        <p:txBody>
+          <a:bodyPr wrap="square"/>
+          <a:lstStyle/>
+          <a:p>
+            <a:pPr>
+              <a:defRPr b="1" sz="1700">
+                <a:solidFill>
+                  <a:srgbClr val="1E293B"/>
+                </a:solidFill>
+              </a:defRPr>
+            </a:pPr>
+            <a:r>
+              <a:t>이용약관(환불)</a:t>
+            </a:r>
+          </a:p>
+          <a:p>
+            <a:pPr>
+              <a:defRPr b="0" sz="1300">
+                <a:solidFill>
+                  <a:srgbClr val="475569"/>
+                </a:solidFill>
+              </a:defRPr>
+            </a:pPr>
+            <a:r>
+              <a:t>충전 후 미사용 포인트 7일 이내 원 결제수단 100% 전액 환불 규정</a:t>
+            </a:r>
+          </a:p>
+        </p:txBody>
+      </p:sp>
+      <p:pic>
+        <p:nvPicPr>
+          <p:cNvPr id="3" name="Picture 2" descr="10_point_refund_policy.png"/>
+          <p:cNvPicPr>
+            <a:picLocks noChangeAspect="1"/>
+          </p:cNvPicPr>
+          <p:nvPr/>
+        </p:nvPicPr>
+        <p:blipFill>
+          <a:blip r:embed="rId2"/>
+          <a:stretch>
+            <a:fillRect/>
+          </a:stretch>
+        </p:blipFill>
+        <p:spPr>
+          <a:xfrm>
+            <a:off x="899667" y="850000"/>
+            <a:ext cx="8106666" cy="5700000"/>
+          </a:xfrm>
+          <a:prstGeom prst="rect">
+            <a:avLst/>
+          </a:prstGeom>
+        </p:spPr>
+      </p:pic>
+    </p:spTree>
+    <p:extLst>
+      <p:ext uri="{BB962C8B-B14F-4D97-AF65-F5344CB8AC3E}">
+        <p14:creationId xmlns:p14="http://schemas.microsoft.com/office/powerpoint/2010/main" val="3360134128"/>
       </p:ext>
     </p:extLst>
   </p:cSld>

</xml_diff>

<commit_message>
feat: Add Danal point usage, refund terms and scope slides with LuckyPick captures
</commit_message>
<xml_diff>
--- a/신용카드 검수요청서(럭키픽).pptx
+++ b/신용카드 검수요청서(럭키픽).pptx
@@ -7659,8 +7659,8 @@
         </p:nvSpPr>
         <p:spPr>
           <a:xfrm>
-            <a:off x="300000" y="120000"/>
-            <a:ext cx="9300000" cy="650000"/>
+            <a:off x="350000" y="120000"/>
+            <a:ext cx="6000000" cy="650000"/>
           </a:xfrm>
           <a:prstGeom prst="rect">
             <a:avLst/>
@@ -7674,7 +7674,7 @@
           <a:lstStyle/>
           <a:p>
             <a:pPr>
-              <a:defRPr b="1" sz="1700">
+              <a:defRPr b="1" sz="1800">
                 <a:solidFill>
                   <a:srgbClr val="1E293B"/>
                 </a:solidFill>
@@ -7686,200 +7686,30 @@
           </a:p>
         </p:txBody>
       </p:sp>
-      <p:sp>
-        <p:nvSpPr>
-          <p:cNvPr id="3" name="TextBox 2"/>
-          <p:cNvSpPr txBox="1"/>
+      <p:pic>
+        <p:nvPicPr>
+          <p:cNvPr id="3" name="Picture 2" descr="10_point_scope_v2.png"/>
+          <p:cNvPicPr>
+            <a:picLocks noChangeAspect="1"/>
+          </p:cNvPicPr>
           <p:nvPr/>
-        </p:nvSpPr>
-        <p:spPr>
-          <a:xfrm>
-            <a:off x="600000" y="1600000"/>
-            <a:ext cx="8700000" cy="1000000"/>
-          </a:xfrm>
-          <a:prstGeom prst="rect">
-            <a:avLst/>
-          </a:prstGeom>
-          <a:noFill/>
-        </p:spPr>
-        <p:txBody>
-          <a:bodyPr wrap="square">
-            <a:spAutoFit/>
-          </a:bodyPr>
-          <a:lstStyle/>
-          <a:p>
-            <a:pPr algn="l">
-              <a:defRPr b="1" sz="2600">
-                <a:solidFill>
-                  <a:srgbClr val="DC2626"/>
-                </a:solidFill>
-              </a:defRPr>
-            </a:pPr>
-            <a:r>
-              <a:t>해당 사이트에서만 포인트 사용이 가능합니다.</a:t>
-            </a:r>
-          </a:p>
-        </p:txBody>
-      </p:sp>
-      <p:sp>
-        <p:nvSpPr>
-          <p:cNvPr id="4" name="TextBox 3"/>
-          <p:cNvSpPr txBox="1"/>
-          <p:nvPr/>
-        </p:nvSpPr>
-        <p:spPr>
-          <a:xfrm>
-            <a:off x="600000" y="2700000"/>
-            <a:ext cx="8700000" cy="3600000"/>
-          </a:xfrm>
-          <a:prstGeom prst="rect">
-            <a:avLst/>
-          </a:prstGeom>
-          <a:noFill/>
-        </p:spPr>
-        <p:txBody>
-          <a:bodyPr wrap="square">
-            <a:spAutoFit/>
-          </a:bodyPr>
-          <a:lstStyle/>
-          <a:p>
-            <a:pPr>
-              <a:spcBef>
-                <a:spcPts val="800"/>
-              </a:spcBef>
-              <a:defRPr b="1" sz="1400">
-                <a:solidFill>
-                  <a:srgbClr val="0F172A"/>
-                </a:solidFill>
-              </a:defRPr>
-            </a:pPr>
-            <a:r>
-              <a:t>1. 포인트 사용 가능 사이트</a:t>
-            </a:r>
-          </a:p>
-          <a:p>
-            <a:pPr>
-              <a:spcAft>
-                <a:spcPts val="600"/>
-              </a:spcAft>
-              <a:defRPr sz="1200">
-                <a:solidFill>
-                  <a:srgbClr val="475569"/>
-                </a:solidFill>
-              </a:defRPr>
-            </a:pPr>
-            <a:r>
-              <a:t>• 공식 서비스 URL: https://luckypick-ec4cf.web.app (럭키픽 온라인 플랫폼 전용)</a:t>
-            </a:r>
-            <a:br/>
-            <a:r>
-              <a:t>• 당사 사이트 외 타 사이트, 오프라인 매장 등에서는 일체 사용이 불가능합니다.</a:t>
-            </a:r>
-          </a:p>
-          <a:p>
-            <a:pPr>
-              <a:spcBef>
-                <a:spcPts val="800"/>
-              </a:spcBef>
-              <a:defRPr b="1" sz="1400">
-                <a:solidFill>
-                  <a:srgbClr val="0F172A"/>
-                </a:solidFill>
-              </a:defRPr>
-            </a:pPr>
-            <a:r>
-              <a:t>2. 포인트 사용 용도</a:t>
-            </a:r>
-          </a:p>
-          <a:p>
-            <a:pPr>
-              <a:spcAft>
-                <a:spcPts val="600"/>
-              </a:spcAft>
-              <a:defRPr sz="1200">
-                <a:solidFill>
-                  <a:srgbClr val="475569"/>
-                </a:solidFill>
-              </a:defRPr>
-            </a:pPr>
-            <a:r>
-              <a:t>• 럭키픽 플랫폼 내 블라인드 큐레이션 럭키박스(베이직, 프리미엄, VIP) 개봉 이용</a:t>
-            </a:r>
-            <a:br/>
-            <a:r>
-              <a:t>• 실물 득템 상품 보관함 출고 시 택배 배송비(3,000P) 결제 이용</a:t>
-            </a:r>
-          </a:p>
-          <a:p>
-            <a:pPr>
-              <a:spcBef>
-                <a:spcPts val="800"/>
-              </a:spcBef>
-              <a:defRPr b="1" sz="1400">
-                <a:solidFill>
-                  <a:srgbClr val="0F172A"/>
-                </a:solidFill>
-              </a:defRPr>
-            </a:pPr>
-            <a:r>
-              <a:t>3. 환금성 및 외부 유출 원천 차단 (비환금성 준수)</a:t>
-            </a:r>
-          </a:p>
-          <a:p>
-            <a:pPr>
-              <a:spcAft>
-                <a:spcPts val="600"/>
-              </a:spcAft>
-              <a:defRPr sz="1200">
-                <a:solidFill>
-                  <a:srgbClr val="475569"/>
-                </a:solidFill>
-              </a:defRPr>
-            </a:pPr>
-            <a:r>
-              <a:t>• 현금 환전 및 계좌 인출이 절대 불가능합니다. (환금성 0%)</a:t>
-            </a:r>
-            <a:br/>
-            <a:r>
-              <a:t>• 회원 간 포인트 선물, 양도, 이전 및 장외 개인 간 거래가 시스템상 원천 차단되어 있습니다.</a:t>
-            </a:r>
-          </a:p>
-          <a:p>
-            <a:pPr>
-              <a:spcBef>
-                <a:spcPts val="800"/>
-              </a:spcBef>
-              <a:defRPr b="1" sz="1400">
-                <a:solidFill>
-                  <a:srgbClr val="0F172A"/>
-                </a:solidFill>
-              </a:defRPr>
-            </a:pPr>
-            <a:r>
-              <a:t>4. 미사용 포인트 청약철회 및 환불 원칙</a:t>
-            </a:r>
-          </a:p>
-          <a:p>
-            <a:pPr>
-              <a:spcAft>
-                <a:spcPts val="600"/>
-              </a:spcAft>
-              <a:defRPr sz="1200">
-                <a:solidFill>
-                  <a:srgbClr val="475569"/>
-                </a:solidFill>
-              </a:defRPr>
-            </a:pPr>
-            <a:r>
-              <a:t>• 유료 결제로 충전한 후 사용하지 않은 잔여 포인트는 결제일로부터 7일 이내 요청 시 구매자의 원 결제수단(신용카드 승인 취소, 휴대폰 소액결제 승인 취소)으로 100% 전액 환불 처리됩니다.</a:t>
-            </a:r>
-            <a:br/>
-            <a:r>
-              <a:t>• 별도의 현금 지급이나 계좌 송금 형태의 환불은 전자상거래법 및 PG사 규정에 따라 불가합니다.</a:t>
-            </a:r>
-          </a:p>
-        </p:txBody>
-      </p:sp>
+        </p:nvPicPr>
+        <p:blipFill>
+          <a:blip r:embed="rId2"/>
+          <a:stretch>
+            <a:fillRect/>
+          </a:stretch>
+        </p:blipFill>
+        <p:spPr>
+          <a:xfrm>
+            <a:off x="400000" y="1597673"/>
+            <a:ext cx="9106000" cy="4304654"/>
+          </a:xfrm>
+          <a:prstGeom prst="rect">
+            <a:avLst/>
+          </a:prstGeom>
+        </p:spPr>
+      </p:pic>
     </p:spTree>
     <p:extLst>
       <p:ext uri="{BB962C8B-B14F-4D97-AF65-F5344CB8AC3E}">
@@ -8040,7 +7870,7 @@
           <a:lstStyle/>
           <a:p>
             <a:pPr>
-              <a:defRPr b="1" sz="1700">
+              <a:defRPr b="1" sz="1800">
                 <a:solidFill>
                   <a:srgbClr val="1E293B"/>
                 </a:solidFill>
@@ -8052,7 +7882,7 @@
           </a:p>
           <a:p>
             <a:pPr>
-              <a:defRPr b="0" sz="1300">
+              <a:defRPr b="0" sz="1200">
                 <a:solidFill>
                   <a:srgbClr val="475569"/>
                 </a:solidFill>
@@ -8080,7 +7910,7 @@
         </p:blipFill>
         <p:spPr>
           <a:xfrm>
-            <a:off x="400000" y="1214606"/>
+            <a:off x="400000" y="1244606"/>
             <a:ext cx="9106000" cy="4970787"/>
           </a:xfrm>
           <a:prstGeom prst="rect">
@@ -8141,7 +7971,7 @@
           <a:lstStyle/>
           <a:p>
             <a:pPr>
-              <a:defRPr b="1" sz="1700">
+              <a:defRPr b="1" sz="1800">
                 <a:solidFill>
                   <a:srgbClr val="1E293B"/>
                 </a:solidFill>
@@ -8153,7 +7983,7 @@
           </a:p>
           <a:p>
             <a:pPr>
-              <a:defRPr b="0" sz="1300">
+              <a:defRPr b="0" sz="1200">
                 <a:solidFill>
                   <a:srgbClr val="475569"/>
                 </a:solidFill>
@@ -8181,7 +8011,7 @@
         </p:blipFill>
         <p:spPr>
           <a:xfrm>
-            <a:off x="1764346" y="850000"/>
+            <a:off x="1764346" y="880000"/>
             <a:ext cx="6377308" cy="5700000"/>
           </a:xfrm>
           <a:prstGeom prst="rect">
@@ -8242,7 +8072,7 @@
           <a:lstStyle/>
           <a:p>
             <a:pPr>
-              <a:defRPr b="1" sz="1700">
+              <a:defRPr b="1" sz="1800">
                 <a:solidFill>
                   <a:srgbClr val="1E293B"/>
                 </a:solidFill>
@@ -8254,7 +8084,7 @@
           </a:p>
           <a:p>
             <a:pPr>
-              <a:defRPr b="0" sz="1300">
+              <a:defRPr b="0" sz="1200">
                 <a:solidFill>
                   <a:srgbClr val="475569"/>
                 </a:solidFill>
@@ -8329,7 +8159,7 @@
         </p:blipFill>
         <p:spPr>
           <a:xfrm>
-            <a:off x="899667" y="850000"/>
+            <a:off x="899667" y="880000"/>
             <a:ext cx="8106666" cy="5700000"/>
           </a:xfrm>
           <a:prstGeom prst="rect">
@@ -8390,7 +8220,7 @@
           <a:lstStyle/>
           <a:p>
             <a:pPr>
-              <a:defRPr b="1" sz="1700">
+              <a:defRPr b="1" sz="1800">
                 <a:solidFill>
                   <a:srgbClr val="1E293B"/>
                 </a:solidFill>
@@ -8402,7 +8232,7 @@
           </a:p>
           <a:p>
             <a:pPr>
-              <a:defRPr b="0" sz="1300">
+              <a:defRPr b="0" sz="1200">
                 <a:solidFill>
                   <a:srgbClr val="475569"/>
                 </a:solidFill>
@@ -8477,7 +8307,7 @@
         </p:blipFill>
         <p:spPr>
           <a:xfrm>
-            <a:off x="899667" y="850000"/>
+            <a:off x="899667" y="880000"/>
             <a:ext cx="8106666" cy="5700000"/>
           </a:xfrm>
           <a:prstGeom prst="rect">
@@ -8538,7 +8368,7 @@
           <a:lstStyle/>
           <a:p>
             <a:pPr>
-              <a:defRPr b="1" sz="1700">
+              <a:defRPr b="1" sz="1800">
                 <a:solidFill>
                   <a:srgbClr val="1E293B"/>
                 </a:solidFill>
@@ -8550,7 +8380,7 @@
           </a:p>
           <a:p>
             <a:pPr>
-              <a:defRPr b="0" sz="1300">
+              <a:defRPr b="0" sz="1200">
                 <a:solidFill>
                   <a:srgbClr val="475569"/>
                 </a:solidFill>
@@ -8578,7 +8408,7 @@
         </p:blipFill>
         <p:spPr>
           <a:xfrm>
-            <a:off x="1583023" y="850000"/>
+            <a:off x="1583023" y="880000"/>
             <a:ext cx="6739953" cy="5700000"/>
           </a:xfrm>
           <a:prstGeom prst="rect">
@@ -8639,7 +8469,7 @@
           <a:lstStyle/>
           <a:p>
             <a:pPr>
-              <a:defRPr b="1" sz="1700">
+              <a:defRPr b="1" sz="1800">
                 <a:solidFill>
                   <a:srgbClr val="1E293B"/>
                 </a:solidFill>
@@ -8651,7 +8481,7 @@
           </a:p>
           <a:p>
             <a:pPr>
-              <a:defRPr b="0" sz="1300">
+              <a:defRPr b="0" sz="1200">
                 <a:solidFill>
                   <a:srgbClr val="475569"/>
                 </a:solidFill>
@@ -8679,7 +8509,7 @@
         </p:blipFill>
         <p:spPr>
           <a:xfrm>
-            <a:off x="1808172" y="850000"/>
+            <a:off x="1808172" y="880000"/>
             <a:ext cx="6289655" cy="5700000"/>
           </a:xfrm>
           <a:prstGeom prst="rect">
@@ -8732,8 +8562,8 @@
         </p:nvSpPr>
         <p:spPr>
           <a:xfrm>
-            <a:off x="300000" y="120000"/>
-            <a:ext cx="9300000" cy="650000"/>
+            <a:off x="350000" y="120000"/>
+            <a:ext cx="6000000" cy="650000"/>
           </a:xfrm>
           <a:prstGeom prst="rect">
             <a:avLst/>
@@ -8747,7 +8577,7 @@
           <a:lstStyle/>
           <a:p>
             <a:pPr>
-              <a:defRPr b="1" sz="1700">
+              <a:defRPr b="1" sz="1800">
                 <a:solidFill>
                   <a:srgbClr val="1E293B"/>
                 </a:solidFill>
@@ -8757,23 +8587,58 @@
               <a:t>포인트 사용 프로세스</a:t>
             </a:r>
           </a:p>
-          <a:p>
-            <a:pPr>
-              <a:defRPr b="0" sz="1300">
-                <a:solidFill>
-                  <a:srgbClr val="475569"/>
+        </p:txBody>
+      </p:sp>
+      <p:sp>
+        <p:nvSpPr>
+          <p:cNvPr id="3" name="TextBox 2"/>
+          <p:cNvSpPr txBox="1"/>
+          <p:nvPr/>
+        </p:nvSpPr>
+        <p:spPr>
+          <a:xfrm>
+            <a:off x="5000000" y="100000"/>
+            <a:ext cx="4500000" cy="650000"/>
+          </a:xfrm>
+          <a:prstGeom prst="rect">
+            <a:avLst/>
+          </a:prstGeom>
+          <a:noFill/>
+        </p:spPr>
+        <p:txBody>
+          <a:bodyPr wrap="square">
+            <a:spAutoFit/>
+          </a:bodyPr>
+          <a:lstStyle/>
+          <a:p>
+            <a:pPr algn="r">
+              <a:defRPr sz="1300" b="1">
+                <a:solidFill>
+                  <a:srgbClr val="1E293B"/>
                 </a:solidFill>
               </a:defRPr>
             </a:pPr>
             <a:r>
-              <a:t>원하는 럭키박스 선택 후 개봉을 진행하면 충전된 포인트에서 차감됩니다</a:t>
+              <a:t>원하는 서비스 및 수량 선택 후</a:t>
+            </a:r>
+          </a:p>
+          <a:p>
+            <a:pPr algn="r">
+              <a:defRPr sz="1300" b="1">
+                <a:solidFill>
+                  <a:srgbClr val="1E293B"/>
+                </a:solidFill>
+              </a:defRPr>
+            </a:pPr>
+            <a:r>
+              <a:t>결제를 진행하면 충전된 포인트에서 차감됩니다</a:t>
             </a:r>
           </a:p>
         </p:txBody>
       </p:sp>
       <p:pic>
         <p:nvPicPr>
-          <p:cNvPr id="3" name="Picture 2" descr="09_point_use_process.png"/>
+          <p:cNvPr id="4" name="Picture 3" descr="08_point_use_process_v2.png"/>
           <p:cNvPicPr>
             <a:picLocks noChangeAspect="1"/>
           </p:cNvPicPr>
@@ -8787,8 +8652,8 @@
         </p:blipFill>
         <p:spPr>
           <a:xfrm>
-            <a:off x="899667" y="850000"/>
-            <a:ext cx="8106666" cy="5700000"/>
+            <a:off x="400000" y="1266545"/>
+            <a:ext cx="9106000" cy="4966909"/>
           </a:xfrm>
           <a:prstGeom prst="rect">
             <a:avLst/>
@@ -8848,7 +8713,7 @@
           <a:lstStyle/>
           <a:p>
             <a:pPr>
-              <a:defRPr b="1" sz="1700">
+              <a:defRPr b="1" sz="1800">
                 <a:solidFill>
                   <a:srgbClr val="1E293B"/>
                 </a:solidFill>
@@ -8858,23 +8723,11 @@
               <a:t>이용약관(환불)</a:t>
             </a:r>
           </a:p>
-          <a:p>
-            <a:pPr>
-              <a:defRPr b="0" sz="1300">
-                <a:solidFill>
-                  <a:srgbClr val="475569"/>
-                </a:solidFill>
-              </a:defRPr>
-            </a:pPr>
-            <a:r>
-              <a:t>충전 후 미사용 포인트 7일 이내 원 결제수단 100% 전액 환불 규정</a:t>
-            </a:r>
-          </a:p>
         </p:txBody>
       </p:sp>
       <p:pic>
         <p:nvPicPr>
-          <p:cNvPr id="3" name="Picture 2" descr="10_point_refund_policy.png"/>
+          <p:cNvPr id="3" name="Picture 2" descr="09_refund_terms_v2.png"/>
           <p:cNvPicPr>
             <a:picLocks noChangeAspect="1"/>
           </p:cNvPicPr>
@@ -8888,8 +8741,8 @@
         </p:blipFill>
         <p:spPr>
           <a:xfrm>
-            <a:off x="899667" y="850000"/>
-            <a:ext cx="8106666" cy="5700000"/>
+            <a:off x="400000" y="1597673"/>
+            <a:ext cx="9106000" cy="4304654"/>
           </a:xfrm>
           <a:prstGeom prst="rect">
             <a:avLst/>

</xml_diff>